<commit_message>
P-20: mark slide 3's unconfirmed live link as in progress (#165 review)
Slide 3's system diagram drew the capture app's HTTPS link to the
reconstruction service in the same solid "Done" style as the built
stages, while the live connection (C-13) was not confirmed by the
15 October cutoff; the caveat lived only in the presenter notes. The
connector now uses slide 13's own "In progress" style (accent2, dashed)
and carries "live link not yet confirmed" on the slide, so a reader of
the .pptx sees the same boundary the speaker states. The capture app
box stays "Done": the app itself was built (C-01..C-12).

Deck rebuilt from the script; only slide 3's text changed. Picture
alt-text paths are written repo-relative instead of the build folder's
absolute path.

Co-Authored-By: Claude Opus 5.5 (1M context) <noreply@anthropic.com>
</commit_message>
<xml_diff>
--- a/submissions/midterm-presentation-deck.pptx
+++ b/submissions/midterm-presentation-deck.pptx
@@ -121,13 +121,13 @@
   <p:extLst>
     <p:ext uri="{521415D9-36F7-43E2-AB2F-B90AF26B5E84}">
       <p14:sectionLst xmlns:p14="http://schemas.microsoft.com/office/powerpoint/2010/main">
-        <p14:section name="Introduction" id="{eee86fc5-7660-f058-b6cf-1f54392fbc94}">
+        <p14:section name="Introduction" id="{30694cb6-1566-a438-c9f0-b8eab43d3270}">
           <p14:sldIdLst>
             <p14:sldId id="256"/>
             <p14:sldId id="257"/>
           </p14:sldIdLst>
         </p14:section>
-        <p14:section name="Completed work" id="{ec886628-aefd-af6f-def6-b09f87bacca6}">
+        <p14:section name="Completed work" id="{e6eb73ba-983c-51ab-096d-fbfe86258a8c}">
           <p14:sldIdLst>
             <p14:sldId id="258"/>
             <p14:sldId id="259"/>
@@ -141,7 +141,7 @@
             <p14:sldId id="267"/>
           </p14:sldIdLst>
         </p14:section>
-        <p14:section name="Plan" id="{38ac450e-0cce-1e64-2ade-2186724df604}">
+        <p14:section name="Plan" id="{03054731-af21-f408-43d7-42f83c4bbfa9}">
           <p14:sldIdLst>
             <p14:sldId id="268"/>
             <p14:sldId id="269"/>
@@ -3379,7 +3379,7 @@
       </p:grpSpPr>
       <p:pic>
         <p:nvPicPr>
-          <p:cNvPr id="2" name="Image 0" descr="/private/tmp/ps-deck-wt/submissions/assets/2026-10-16/fig_photo_s05.jpg">    </p:cNvPr>
+          <p:cNvPr id="2" name="Image 0" descr="submissions/assets/2026-10-16/fig_photo_s05.jpg">    </p:cNvPr>
           <p:cNvPicPr>
             <a:picLocks noChangeAspect="1"/>
           </p:cNvPicPr>
@@ -4729,7 +4729,7 @@
       </p:sp>
       <p:pic>
         <p:nvPicPr>
-          <p:cNvPr id="5" name="Image 0" descr="/private/tmp/ps-deck-wt/submissions/assets/2026-10-16/fig_confidence.jpg">    </p:cNvPr>
+          <p:cNvPr id="5" name="Image 0" descr="submissions/assets/2026-10-16/fig_confidence.jpg">    </p:cNvPr>
           <p:cNvPicPr>
             <a:picLocks noChangeAspect="1"/>
           </p:cNvPicPr>
@@ -13324,9 +13324,9 @@
           <a:noFill/>
           <a:ln w="19050">
             <a:solidFill>
-              <a:schemeClr val="accent4"/>
+              <a:schemeClr val="accent2"/>
             </a:solidFill>
-            <a:prstDash val="solid"/>
+            <a:prstDash val="dash"/>
             <a:headEnd type="triangle"/>
             <a:tailEnd type="triangle"/>
           </a:ln>
@@ -13384,7 +13384,71 @@
       </p:sp>
       <p:sp>
         <p:nvSpPr>
-          <p:cNvPr id="11" name="Shape 8"/>
+          <p:cNvPr id="11" name="Text 8"/>
+          <p:cNvSpPr txBox="1"/>
+          <p:nvPr/>
+        </p:nvSpPr>
+        <p:spPr>
+          <a:xfrm>
+            <a:off x="2615184" y="2715768"/>
+            <a:ext cx="804672" cy="566928"/>
+          </a:xfrm>
+          <a:prstGeom prst="rect">
+            <a:avLst/>
+          </a:prstGeom>
+          <a:noFill/>
+          <a:ln/>
+        </p:spPr>
+        <p:txBody>
+          <a:bodyPr wrap="square" lIns="0" tIns="0" rIns="0" bIns="0" rtlCol="0" anchor="t"/>
+          <a:lstStyle/>
+          <a:p>
+            <a:pPr algn="ctr" indent="0" marL="0">
+              <a:buNone/>
+            </a:pPr>
+            <a:r>
+              <a:rPr lang="en-US" sz="900" i="1" dirty="0">
+                <a:solidFill>
+                  <a:schemeClr val="accent2"/>
+                </a:solidFill>
+              </a:rPr>
+              <a:t>live link</a:t>
+            </a:r>
+            <a:endParaRPr lang="en-US" sz="900" dirty="0"/>
+          </a:p>
+          <a:p>
+            <a:pPr algn="ctr" indent="0" marL="0">
+              <a:buNone/>
+            </a:pPr>
+            <a:r>
+              <a:rPr lang="en-US" sz="900" i="1" dirty="0">
+                <a:solidFill>
+                  <a:schemeClr val="accent2"/>
+                </a:solidFill>
+              </a:rPr>
+              <a:t>not yet</a:t>
+            </a:r>
+            <a:endParaRPr lang="en-US" sz="900" dirty="0"/>
+          </a:p>
+          <a:p>
+            <a:pPr algn="ctr" indent="0" marL="0">
+              <a:buNone/>
+            </a:pPr>
+            <a:r>
+              <a:rPr lang="en-US" sz="900" i="1" dirty="0">
+                <a:solidFill>
+                  <a:schemeClr val="accent2"/>
+                </a:solidFill>
+              </a:rPr>
+              <a:t>confirmed</a:t>
+            </a:r>
+            <a:endParaRPr lang="en-US" sz="900" dirty="0"/>
+          </a:p>
+        </p:txBody>
+      </p:sp>
+      <p:sp>
+        <p:nvSpPr>
+          <p:cNvPr id="12" name="Shape 9"/>
           <p:cNvSpPr/>
           <p:nvPr/>
         </p:nvSpPr>
@@ -13411,7 +13475,7 @@
       </p:sp>
       <p:sp>
         <p:nvSpPr>
-          <p:cNvPr id="12" name="Text 9"/>
+          <p:cNvPr id="13" name="Text 10"/>
           <p:cNvSpPr txBox="1"/>
           <p:nvPr/>
         </p:nvSpPr>
@@ -13447,7 +13511,7 @@
       </p:sp>
       <p:sp>
         <p:nvSpPr>
-          <p:cNvPr id="13" name="Shape 10"/>
+          <p:cNvPr id="14" name="Shape 11"/>
           <p:cNvSpPr/>
           <p:nvPr/>
         </p:nvSpPr>
@@ -13474,7 +13538,7 @@
       </p:sp>
       <p:sp>
         <p:nvSpPr>
-          <p:cNvPr id="14" name="Text 11"/>
+          <p:cNvPr id="15" name="Text 12"/>
           <p:cNvSpPr txBox="1"/>
           <p:nvPr/>
         </p:nvSpPr>
@@ -13510,7 +13574,7 @@
       </p:sp>
       <p:sp>
         <p:nvSpPr>
-          <p:cNvPr id="15" name="Text 12"/>
+          <p:cNvPr id="16" name="Text 13"/>
           <p:cNvSpPr txBox="1"/>
           <p:nvPr/>
         </p:nvSpPr>
@@ -13560,7 +13624,7 @@
       </p:sp>
       <p:sp>
         <p:nvSpPr>
-          <p:cNvPr id="16" name="Shape 13"/>
+          <p:cNvPr id="17" name="Shape 14"/>
           <p:cNvSpPr/>
           <p:nvPr/>
         </p:nvSpPr>
@@ -13584,7 +13648,7 @@
       </p:sp>
       <p:sp>
         <p:nvSpPr>
-          <p:cNvPr id="17" name="Shape 14"/>
+          <p:cNvPr id="18" name="Shape 15"/>
           <p:cNvSpPr/>
           <p:nvPr/>
         </p:nvSpPr>
@@ -13611,7 +13675,7 @@
       </p:sp>
       <p:sp>
         <p:nvSpPr>
-          <p:cNvPr id="18" name="Text 15"/>
+          <p:cNvPr id="19" name="Text 16"/>
           <p:cNvSpPr txBox="1"/>
           <p:nvPr/>
         </p:nvSpPr>
@@ -13647,7 +13711,7 @@
       </p:sp>
       <p:sp>
         <p:nvSpPr>
-          <p:cNvPr id="19" name="Text 16"/>
+          <p:cNvPr id="20" name="Text 17"/>
           <p:cNvSpPr txBox="1"/>
           <p:nvPr/>
         </p:nvSpPr>
@@ -13697,7 +13761,7 @@
       </p:sp>
       <p:sp>
         <p:nvSpPr>
-          <p:cNvPr id="20" name="Shape 17"/>
+          <p:cNvPr id="21" name="Shape 18"/>
           <p:cNvSpPr/>
           <p:nvPr/>
         </p:nvSpPr>
@@ -13721,7 +13785,7 @@
       </p:sp>
       <p:sp>
         <p:nvSpPr>
-          <p:cNvPr id="21" name="Shape 18"/>
+          <p:cNvPr id="22" name="Shape 19"/>
           <p:cNvSpPr/>
           <p:nvPr/>
         </p:nvSpPr>
@@ -13748,7 +13812,7 @@
       </p:sp>
       <p:sp>
         <p:nvSpPr>
-          <p:cNvPr id="22" name="Text 19"/>
+          <p:cNvPr id="23" name="Text 20"/>
           <p:cNvSpPr txBox="1"/>
           <p:nvPr/>
         </p:nvSpPr>
@@ -13784,7 +13848,7 @@
       </p:sp>
       <p:sp>
         <p:nvSpPr>
-          <p:cNvPr id="23" name="Text 20"/>
+          <p:cNvPr id="24" name="Text 21"/>
           <p:cNvSpPr txBox="1"/>
           <p:nvPr/>
         </p:nvSpPr>
@@ -13834,7 +13898,7 @@
       </p:sp>
       <p:sp>
         <p:nvSpPr>
-          <p:cNvPr id="24" name="Shape 21"/>
+          <p:cNvPr id="25" name="Shape 22"/>
           <p:cNvSpPr/>
           <p:nvPr/>
         </p:nvSpPr>
@@ -13858,7 +13922,7 @@
       </p:sp>
       <p:sp>
         <p:nvSpPr>
-          <p:cNvPr id="25" name="Shape 22"/>
+          <p:cNvPr id="26" name="Shape 23"/>
           <p:cNvSpPr/>
           <p:nvPr/>
         </p:nvSpPr>
@@ -13885,7 +13949,7 @@
       </p:sp>
       <p:sp>
         <p:nvSpPr>
-          <p:cNvPr id="26" name="Text 23"/>
+          <p:cNvPr id="27" name="Text 24"/>
           <p:cNvSpPr txBox="1"/>
           <p:nvPr/>
         </p:nvSpPr>
@@ -13921,7 +13985,7 @@
       </p:sp>
       <p:sp>
         <p:nvSpPr>
-          <p:cNvPr id="27" name="Text 24"/>
+          <p:cNvPr id="28" name="Text 25"/>
           <p:cNvSpPr txBox="1"/>
           <p:nvPr/>
         </p:nvSpPr>
@@ -13971,7 +14035,7 @@
       </p:sp>
       <p:sp>
         <p:nvSpPr>
-          <p:cNvPr id="28" name="Shape 25"/>
+          <p:cNvPr id="29" name="Shape 26"/>
           <p:cNvSpPr/>
           <p:nvPr/>
         </p:nvSpPr>
@@ -13998,7 +14062,7 @@
       </p:sp>
       <p:sp>
         <p:nvSpPr>
-          <p:cNvPr id="29" name="Text 26"/>
+          <p:cNvPr id="30" name="Text 27"/>
           <p:cNvSpPr txBox="1"/>
           <p:nvPr/>
         </p:nvSpPr>
@@ -14034,7 +14098,7 @@
       </p:sp>
       <p:sp>
         <p:nvSpPr>
-          <p:cNvPr id="30" name="Text 27"/>
+          <p:cNvPr id="31" name="Text 28"/>
           <p:cNvSpPr txBox="1"/>
           <p:nvPr/>
         </p:nvSpPr>
@@ -14084,7 +14148,7 @@
       </p:sp>
       <p:sp>
         <p:nvSpPr>
-          <p:cNvPr id="31" name="Shape 28"/>
+          <p:cNvPr id="32" name="Shape 29"/>
           <p:cNvSpPr/>
           <p:nvPr/>
         </p:nvSpPr>
@@ -14108,7 +14172,7 @@
       </p:sp>
       <p:sp>
         <p:nvSpPr>
-          <p:cNvPr id="32" name="Shape 29"/>
+          <p:cNvPr id="33" name="Shape 30"/>
           <p:cNvSpPr/>
           <p:nvPr/>
         </p:nvSpPr>
@@ -14135,7 +14199,7 @@
       </p:sp>
       <p:sp>
         <p:nvSpPr>
-          <p:cNvPr id="33" name="Text 30"/>
+          <p:cNvPr id="34" name="Text 31"/>
           <p:cNvSpPr txBox="1"/>
           <p:nvPr/>
         </p:nvSpPr>
@@ -14171,7 +14235,7 @@
       </p:sp>
       <p:sp>
         <p:nvSpPr>
-          <p:cNvPr id="34" name="Text 31"/>
+          <p:cNvPr id="35" name="Text 32"/>
           <p:cNvSpPr txBox="1"/>
           <p:nvPr/>
         </p:nvSpPr>
@@ -14207,7 +14271,7 @@
       </p:sp>
       <p:sp>
         <p:nvSpPr>
-          <p:cNvPr id="35" name="Shape 32"/>
+          <p:cNvPr id="36" name="Shape 33"/>
           <p:cNvSpPr/>
           <p:nvPr/>
         </p:nvSpPr>
@@ -14231,7 +14295,7 @@
       </p:sp>
       <p:sp>
         <p:nvSpPr>
-          <p:cNvPr id="36" name="Shape 33"/>
+          <p:cNvPr id="37" name="Shape 34"/>
           <p:cNvSpPr/>
           <p:nvPr/>
         </p:nvSpPr>
@@ -14258,7 +14322,7 @@
       </p:sp>
       <p:sp>
         <p:nvSpPr>
-          <p:cNvPr id="37" name="Text 34"/>
+          <p:cNvPr id="38" name="Text 35"/>
           <p:cNvSpPr txBox="1"/>
           <p:nvPr/>
         </p:nvSpPr>
@@ -14294,7 +14358,7 @@
       </p:sp>
       <p:sp>
         <p:nvSpPr>
-          <p:cNvPr id="38" name="Text 35"/>
+          <p:cNvPr id="39" name="Text 36"/>
           <p:cNvSpPr txBox="1"/>
           <p:nvPr/>
         </p:nvSpPr>
@@ -14344,7 +14408,7 @@
       </p:sp>
       <p:sp>
         <p:nvSpPr>
-          <p:cNvPr id="39" name="Shape 36"/>
+          <p:cNvPr id="40" name="Shape 37"/>
           <p:cNvSpPr/>
           <p:nvPr/>
         </p:nvSpPr>
@@ -14368,7 +14432,7 @@
       </p:sp>
       <p:sp>
         <p:nvSpPr>
-          <p:cNvPr id="40" name="Shape 37"/>
+          <p:cNvPr id="41" name="Shape 38"/>
           <p:cNvSpPr/>
           <p:nvPr/>
         </p:nvSpPr>
@@ -14395,7 +14459,7 @@
       </p:sp>
       <p:sp>
         <p:nvSpPr>
-          <p:cNvPr id="41" name="Text 38"/>
+          <p:cNvPr id="42" name="Text 39"/>
           <p:cNvSpPr txBox="1"/>
           <p:nvPr/>
         </p:nvSpPr>
@@ -14431,7 +14495,7 @@
       </p:sp>
       <p:sp>
         <p:nvSpPr>
-          <p:cNvPr id="42" name="Text 39"/>
+          <p:cNvPr id="43" name="Text 40"/>
           <p:cNvSpPr txBox="1"/>
           <p:nvPr/>
         </p:nvSpPr>
@@ -14481,7 +14545,7 @@
       </p:sp>
       <p:sp>
         <p:nvSpPr>
-          <p:cNvPr id="43" name="Text 40"/>
+          <p:cNvPr id="44" name="Text 41"/>
           <p:cNvSpPr txBox="1"/>
           <p:nvPr/>
         </p:nvSpPr>
@@ -14517,7 +14581,7 @@
       </p:sp>
       <p:sp>
         <p:nvSpPr>
-          <p:cNvPr id="44" name="Shape 41"/>
+          <p:cNvPr id="45" name="Shape 42"/>
           <p:cNvSpPr/>
           <p:nvPr/>
         </p:nvSpPr>
@@ -14544,7 +14608,7 @@
       </p:sp>
       <p:pic>
         <p:nvPicPr>
-          <p:cNvPr id="45" name="Image 1" descr="preencoded.png">    </p:cNvPr>
+          <p:cNvPr id="46" name="Image 1" descr="preencoded.png">    </p:cNvPr>
           <p:cNvPicPr>
             <a:picLocks noChangeAspect="1"/>
           </p:cNvPicPr>
@@ -14568,7 +14632,7 @@
       </p:pic>
       <p:sp>
         <p:nvSpPr>
-          <p:cNvPr id="46" name="Text 42"/>
+          <p:cNvPr id="47" name="Text 43"/>
           <p:cNvSpPr txBox="1"/>
           <p:nvPr/>
         </p:nvSpPr>
@@ -14607,7 +14671,7 @@
       </p:sp>
       <p:sp>
         <p:nvSpPr>
-          <p:cNvPr id="47" name="Text 43"/>
+          <p:cNvPr id="48" name="Text 44"/>
           <p:cNvSpPr txBox="1"/>
           <p:nvPr/>
         </p:nvSpPr>
@@ -14643,7 +14707,7 @@
       </p:sp>
       <p:sp>
         <p:nvSpPr>
-          <p:cNvPr id="48" name="Text 44"/>
+          <p:cNvPr id="49" name="Text 45"/>
           <p:cNvSpPr txBox="1"/>
           <p:nvPr/>
         </p:nvSpPr>
@@ -14679,7 +14743,7 @@
       </p:sp>
       <p:sp>
         <p:nvSpPr>
-          <p:cNvPr id="49" name="Shape 45"/>
+          <p:cNvPr id="50" name="Shape 46"/>
           <p:cNvSpPr/>
           <p:nvPr/>
         </p:nvSpPr>
@@ -14706,7 +14770,7 @@
       </p:sp>
       <p:pic>
         <p:nvPicPr>
-          <p:cNvPr id="50" name="Image 2" descr="preencoded.png">    </p:cNvPr>
+          <p:cNvPr id="51" name="Image 2" descr="preencoded.png">    </p:cNvPr>
           <p:cNvPicPr>
             <a:picLocks noChangeAspect="1"/>
           </p:cNvPicPr>
@@ -14730,7 +14794,7 @@
       </p:pic>
       <p:sp>
         <p:nvSpPr>
-          <p:cNvPr id="51" name="Text 46"/>
+          <p:cNvPr id="52" name="Text 47"/>
           <p:cNvSpPr txBox="1"/>
           <p:nvPr/>
         </p:nvSpPr>
@@ -14769,7 +14833,7 @@
       </p:sp>
       <p:sp>
         <p:nvSpPr>
-          <p:cNvPr id="52" name="Text 47"/>
+          <p:cNvPr id="53" name="Text 48"/>
           <p:cNvSpPr txBox="1"/>
           <p:nvPr/>
         </p:nvSpPr>
@@ -14805,7 +14869,7 @@
       </p:sp>
       <p:sp>
         <p:nvSpPr>
-          <p:cNvPr id="53" name="Text 48"/>
+          <p:cNvPr id="54" name="Text 49"/>
           <p:cNvSpPr txBox="1"/>
           <p:nvPr/>
         </p:nvSpPr>
@@ -14841,7 +14905,7 @@
       </p:sp>
       <p:sp>
         <p:nvSpPr>
-          <p:cNvPr id="54" name="Shape 49"/>
+          <p:cNvPr id="55" name="Shape 50"/>
           <p:cNvSpPr/>
           <p:nvPr/>
         </p:nvSpPr>
@@ -14868,7 +14932,7 @@
       </p:sp>
       <p:pic>
         <p:nvPicPr>
-          <p:cNvPr id="55" name="Image 3" descr="preencoded.png">    </p:cNvPr>
+          <p:cNvPr id="56" name="Image 3" descr="preencoded.png">    </p:cNvPr>
           <p:cNvPicPr>
             <a:picLocks noChangeAspect="1"/>
           </p:cNvPicPr>
@@ -14892,7 +14956,7 @@
       </p:pic>
       <p:sp>
         <p:nvSpPr>
-          <p:cNvPr id="56" name="Text 50"/>
+          <p:cNvPr id="57" name="Text 51"/>
           <p:cNvSpPr txBox="1"/>
           <p:nvPr/>
         </p:nvSpPr>
@@ -14931,7 +14995,7 @@
       </p:sp>
       <p:sp>
         <p:nvSpPr>
-          <p:cNvPr id="57" name="Text 51"/>
+          <p:cNvPr id="58" name="Text 52"/>
           <p:cNvSpPr txBox="1"/>
           <p:nvPr/>
         </p:nvSpPr>
@@ -14967,7 +15031,7 @@
       </p:sp>
       <p:sp>
         <p:nvSpPr>
-          <p:cNvPr id="58" name="Text 52"/>
+          <p:cNvPr id="59" name="Text 53"/>
           <p:cNvSpPr txBox="1"/>
           <p:nvPr/>
         </p:nvSpPr>
@@ -15003,7 +15067,7 @@
       </p:sp>
       <p:sp>
         <p:nvSpPr>
-          <p:cNvPr id="59" name="Shape 53"/>
+          <p:cNvPr id="60" name="Shape 54"/>
           <p:cNvSpPr/>
           <p:nvPr/>
         </p:nvSpPr>
@@ -15030,7 +15094,7 @@
       </p:sp>
       <p:pic>
         <p:nvPicPr>
-          <p:cNvPr id="60" name="Image 4" descr="preencoded.png">    </p:cNvPr>
+          <p:cNvPr id="61" name="Image 4" descr="preencoded.png">    </p:cNvPr>
           <p:cNvPicPr>
             <a:picLocks noChangeAspect="1"/>
           </p:cNvPicPr>
@@ -15054,7 +15118,7 @@
       </p:pic>
       <p:sp>
         <p:nvSpPr>
-          <p:cNvPr id="61" name="Text 54"/>
+          <p:cNvPr id="62" name="Text 55"/>
           <p:cNvSpPr txBox="1"/>
           <p:nvPr/>
         </p:nvSpPr>
@@ -15093,7 +15157,7 @@
       </p:sp>
       <p:sp>
         <p:nvSpPr>
-          <p:cNvPr id="62" name="Text 55"/>
+          <p:cNvPr id="63" name="Text 56"/>
           <p:cNvSpPr txBox="1"/>
           <p:nvPr/>
         </p:nvSpPr>
@@ -15129,7 +15193,7 @@
       </p:sp>
       <p:sp>
         <p:nvSpPr>
-          <p:cNvPr id="63" name="Text 56"/>
+          <p:cNvPr id="64" name="Text 57"/>
           <p:cNvSpPr txBox="1"/>
           <p:nvPr/>
         </p:nvSpPr>
@@ -15999,7 +16063,7 @@
       </p:sp>
       <p:pic>
         <p:nvPicPr>
-          <p:cNvPr id="5" name="Image 0" descr="/private/tmp/ps-deck-wt/submissions/assets/2026-10-16/fig_cameras.png">    </p:cNvPr>
+          <p:cNvPr id="5" name="Image 0" descr="submissions/assets/2026-10-16/fig_cameras.png">    </p:cNvPr>
           <p:cNvPicPr>
             <a:picLocks noChangeAspect="1"/>
           </p:cNvPicPr>
@@ -16694,7 +16758,7 @@
       </p:sp>
       <p:pic>
         <p:nvPicPr>
-          <p:cNvPr id="5" name="Image 0" descr="/private/tmp/ps-deck-wt/submissions/assets/2026-10-16/fig_pipeline_strip.jpg">    </p:cNvPr>
+          <p:cNvPr id="5" name="Image 0" descr="submissions/assets/2026-10-16/fig_pipeline_strip.jpg">    </p:cNvPr>
           <p:cNvPicPr>
             <a:picLocks noChangeAspect="1"/>
           </p:cNvPicPr>
@@ -17012,7 +17076,7 @@
       </p:sp>
       <p:pic>
         <p:nvPicPr>
-          <p:cNvPr id="5" name="Image 0" descr="/private/tmp/ps-deck-wt/submissions/assets/2026-10-16/fig_provenance.jpg">    </p:cNvPr>
+          <p:cNvPr id="5" name="Image 0" descr="submissions/assets/2026-10-16/fig_provenance.jpg">    </p:cNvPr>
           <p:cNvPicPr>
             <a:picLocks noChangeAspect="1"/>
           </p:cNvPicPr>
@@ -18035,7 +18099,7 @@
       </p:sp>
       <p:pic>
         <p:nvPicPr>
-          <p:cNvPr id="7" name="Image 0" descr="/private/tmp/ps-deck-wt/submissions/assets/2026-10-16/fig_desktop_capture.jpg">    </p:cNvPr>
+          <p:cNvPr id="7" name="Image 0" descr="submissions/assets/2026-10-16/fig_desktop_capture.jpg">    </p:cNvPr>
           <p:cNvPicPr>
             <a:picLocks noChangeAspect="1"/>
           </p:cNvPicPr>
@@ -18122,7 +18186,7 @@
       </p:sp>
       <p:pic>
         <p:nvPicPr>
-          <p:cNvPr id="10" name="Image 1" descr="/private/tmp/ps-deck-wt/submissions/assets/2026-10-16/fig_desktop_viewer.jpg">    </p:cNvPr>
+          <p:cNvPr id="10" name="Image 1" descr="submissions/assets/2026-10-16/fig_desktop_viewer.jpg">    </p:cNvPr>
           <p:cNvPicPr>
             <a:picLocks noChangeAspect="1"/>
           </p:cNvPicPr>
@@ -19045,7 +19109,7 @@
       </p:sp>
       <p:pic>
         <p:nvPicPr>
-          <p:cNvPr id="5" name="Image 0" descr="/private/tmp/ps-deck-wt/submissions/assets/2026-10-16/fig_nextview.png">    </p:cNvPr>
+          <p:cNvPr id="5" name="Image 0" descr="submissions/assets/2026-10-16/fig_nextview.png">    </p:cNvPr>
           <p:cNvPicPr>
             <a:picLocks noChangeAspect="1"/>
           </p:cNvPicPr>

</xml_diff>